<commit_message>
Adopt Gluon auth spec, company slide template, and PPTX build guards.
Add GLUON.md and imported GLUON-REQUIREMENTS-SPEC; wire CONSTITUTION and README.
Ship validated upscale-company-template with CCC colors and zip-clean build pipeline.

Co-authored-by: Cursor <cursoragent@cursor.com>
</commit_message>
<xml_diff>
--- a/assets/templates/upscale-company-template.pptx
+++ b/assets/templates/upscale-company-template.pptx
@@ -2883,7 +2883,7 @@
             <a:r>
               <a:rPr lang="en-US" sz="2200" b="1" i="0" u="none" strike="noStrike" cap="none">
                 <a:solidFill>
-                  <a:srgbClr val="FFFFFF"/>
+                  <a:srgbClr val="FFE19E"/>
                 </a:solidFill>
                 <a:latin typeface="Calibri"/>
                 <a:ea typeface="Calibri"/>
@@ -3023,7 +3023,7 @@
             <a:r>
               <a:rPr lang="en-US" sz="1950" b="0" i="1" u="none" strike="noStrike" cap="none">
                 <a:solidFill>
-                  <a:srgbClr val="000000"/>
+                  <a:srgbClr val="FEDB8D"/>
                 </a:solidFill>
                 <a:latin typeface="Arial"/>
                 <a:ea typeface="Arial"/>
@@ -3129,7 +3129,7 @@
             <a:r>
               <a:rPr lang="en-US" sz="1100" b="0" i="1" u="none" strike="noStrike" cap="none">
                 <a:solidFill>
-                  <a:srgbClr val="000000"/>
+                  <a:srgbClr val="AABBCC"/>
                 </a:solidFill>
                 <a:latin typeface="Calibri"/>
                 <a:ea typeface="Calibri"/>
@@ -3195,7 +3195,7 @@
             <a:r>
               <a:rPr lang="en-US" sz="1000" b="0" i="0" u="none" strike="noStrike" cap="none">
                 <a:solidFill>
-                  <a:srgbClr val="000000"/>
+                  <a:srgbClr val="778899"/>
                 </a:solidFill>
                 <a:latin typeface="Calibri"/>
                 <a:ea typeface="Calibri"/>
@@ -4355,7 +4355,7 @@
             <a:r>
               <a:rPr lang="en-US" sz="900" b="1" i="0" u="none" strike="noStrike" cap="none">
                 <a:solidFill>
-                  <a:srgbClr val="FFFFFF"/>
+                  <a:srgbClr val="FFE19E"/>
                 </a:solidFill>
                 <a:latin typeface="Calibri"/>
                 <a:ea typeface="Calibri"/>
@@ -4734,7 +4734,7 @@
             <a:r>
               <a:rPr lang="en-US" sz="900" b="1" i="0" u="none" strike="noStrike" cap="none">
                 <a:solidFill>
-                  <a:srgbClr val="333333"/>
+                  <a:srgbClr val="FFE19E"/>
                 </a:solidFill>
                 <a:latin typeface="Calibri"/>
                 <a:ea typeface="Calibri"/>
@@ -4746,7 +4746,7 @@
             <a:r>
               <a:rPr lang="en-US" sz="900" b="0" i="0" u="none" strike="noStrike" cap="none">
                 <a:solidFill>
-                  <a:srgbClr val="4F81BD"/>
+                  <a:srgbClr val="FFE19E"/>
                 </a:solidFill>
                 <a:latin typeface="Calibri"/>
                 <a:ea typeface="Calibri"/>
@@ -4812,7 +4812,7 @@
             <a:r>
               <a:rPr>
                 <a:solidFill>
-                  <a:srgbClr val="000000"/>
+                  <a:srgbClr val="556677"/>
                 </a:solidFill>
               </a:rPr>
               <a:t>[Subtitle or lead line — optional]</a:t>
@@ -4835,7 +4835,7 @@
             <a:r>
               <a:rPr>
                 <a:solidFill>
-                  <a:srgbClr val="000000"/>
+                  <a:srgbClr val="333333"/>
                 </a:solidFill>
               </a:rPr>
               <a:t>[Bullet or paragraph 1]</a:t>
@@ -4846,7 +4846,7 @@
             <a:r>
               <a:rPr>
                 <a:solidFill>
-                  <a:srgbClr val="000000"/>
+                  <a:srgbClr val="333333"/>
                 </a:solidFill>
               </a:rPr>
               <a:t>[Bullet or paragraph 2]</a:t>
@@ -4857,7 +4857,7 @@
             <a:r>
               <a:rPr>
                 <a:solidFill>
-                  <a:srgbClr val="000000"/>
+                  <a:srgbClr val="333333"/>
                 </a:solidFill>
               </a:rPr>
               <a:t>[Bullet or paragraph 3]</a:t>

</xml_diff>